<commit_message>
Complete readme and power point, wait to configure
</commit_message>
<xml_diff>
--- a/MySEProject/Documentation/ML22-23-8 Implement the SDR representation in the MAUI application.pptx
+++ b/MySEProject/Documentation/ML22-23-8 Implement the SDR representation in the MAUI application.pptx
@@ -5,7 +5,7 @@
     <p:sldMasterId id="2147483648" r:id="rId1"/>
   </p:sldMasterIdLst>
   <p:notesMasterIdLst>
-    <p:notesMasterId r:id="rId18"/>
+    <p:notesMasterId r:id="rId19"/>
   </p:notesMasterIdLst>
   <p:sldIdLst>
     <p:sldId id="260" r:id="rId2"/>
@@ -14,16 +14,17 @@
     <p:sldId id="301" r:id="rId5"/>
     <p:sldId id="290" r:id="rId6"/>
     <p:sldId id="306" r:id="rId7"/>
-    <p:sldId id="307" r:id="rId8"/>
-    <p:sldId id="303" r:id="rId9"/>
+    <p:sldId id="303" r:id="rId8"/>
+    <p:sldId id="311" r:id="rId9"/>
     <p:sldId id="302" r:id="rId10"/>
-    <p:sldId id="304" r:id="rId11"/>
-    <p:sldId id="308" r:id="rId12"/>
-    <p:sldId id="309" r:id="rId13"/>
-    <p:sldId id="305" r:id="rId14"/>
-    <p:sldId id="284" r:id="rId15"/>
-    <p:sldId id="285" r:id="rId16"/>
-    <p:sldId id="286" r:id="rId17"/>
+    <p:sldId id="310" r:id="rId11"/>
+    <p:sldId id="304" r:id="rId12"/>
+    <p:sldId id="308" r:id="rId13"/>
+    <p:sldId id="309" r:id="rId14"/>
+    <p:sldId id="305" r:id="rId15"/>
+    <p:sldId id="284" r:id="rId16"/>
+    <p:sldId id="285" r:id="rId17"/>
+    <p:sldId id="286" r:id="rId18"/>
   </p:sldIdLst>
   <p:sldSz cx="9144000" cy="6858000" type="screen4x3"/>
   <p:notesSz cx="6858000" cy="9144000"/>
@@ -124,7 +125,7 @@
   </p:defaultTextStyle>
   <p:extLst>
     <p:ext uri="{EFAFB233-063F-42B5-8137-9DF3F51BA10A}">
-      <p15:sldGuideLst xmlns="" xmlns:p15="http://schemas.microsoft.com/office/powerpoint/2012/main">
+      <p15:sldGuideLst xmlns:p15="http://schemas.microsoft.com/office/powerpoint/2012/main" xmlns="">
         <p15:guide id="1" orient="horz" pos="2160">
           <p15:clr>
             <a:srgbClr val="A4A3A4"/>
@@ -223,7 +224,7 @@
           <a:p>
             <a:fld id="{0DD56E9B-AA6C-4565-9E7F-312A352AD703}" type="datetimeFigureOut">
               <a:rPr lang="en-GB" smtClean="0"/>
-              <a:t>27/03/2024</a:t>
+              <a:t>28/03/2024</a:t>
             </a:fld>
             <a:endParaRPr lang="en-GB"/>
           </a:p>
@@ -2444,7 +2445,7 @@
             <a:fld id="{1D8BD707-D9CF-40AE-B4C6-C98DA3205C09}" type="datetimeFigureOut">
               <a:rPr lang="en-US" smtClean="0"/>
               <a:pPr/>
-              <a:t>3/27/2024</a:t>
+              <a:t>3/28/2024</a:t>
             </a:fld>
             <a:endParaRPr lang="en-US"/>
           </a:p>
@@ -2609,7 +2610,7 @@
             <a:fld id="{1D8BD707-D9CF-40AE-B4C6-C98DA3205C09}" type="datetimeFigureOut">
               <a:rPr lang="en-US" smtClean="0"/>
               <a:pPr/>
-              <a:t>3/27/2024</a:t>
+              <a:t>3/28/2024</a:t>
             </a:fld>
             <a:endParaRPr lang="en-US"/>
           </a:p>
@@ -2784,7 +2785,7 @@
             <a:fld id="{1D8BD707-D9CF-40AE-B4C6-C98DA3205C09}" type="datetimeFigureOut">
               <a:rPr lang="en-US" smtClean="0"/>
               <a:pPr/>
-              <a:t>3/27/2024</a:t>
+              <a:t>3/28/2024</a:t>
             </a:fld>
             <a:endParaRPr lang="en-US"/>
           </a:p>
@@ -8862,7 +8863,7 @@
                 <a:hlinkClick r:id="rId2">
                   <a:extLst>
                     <a:ext uri="{A12FA001-AC4F-418D-AE19-62706E023703}">
-                      <ahyp:hlinkClr xmlns="" xmlns:ahyp="http://schemas.microsoft.com/office/drawing/2018/hyperlinkcolor" val="tx"/>
+                      <ahyp:hlinkClr xmlns:ahyp="http://schemas.microsoft.com/office/drawing/2018/hyperlinkcolor" xmlns="" val="tx"/>
                     </a:ext>
                   </a:extLst>
                 </a:hlinkClick>
@@ -8896,7 +8897,7 @@
                 <a:hlinkClick r:id="rId3">
                   <a:extLst>
                     <a:ext uri="{A12FA001-AC4F-418D-AE19-62706E023703}">
-                      <ahyp:hlinkClr xmlns="" xmlns:ahyp="http://schemas.microsoft.com/office/drawing/2018/hyperlinkcolor" val="tx"/>
+                      <ahyp:hlinkClr xmlns:ahyp="http://schemas.microsoft.com/office/drawing/2018/hyperlinkcolor" xmlns="" val="tx"/>
                     </a:ext>
                   </a:extLst>
                 </a:hlinkClick>
@@ -8930,7 +8931,7 @@
                 <a:hlinkClick r:id="rId4">
                   <a:extLst>
                     <a:ext uri="{A12FA001-AC4F-418D-AE19-62706E023703}">
-                      <ahyp:hlinkClr xmlns="" xmlns:ahyp="http://schemas.microsoft.com/office/drawing/2018/hyperlinkcolor" val="tx"/>
+                      <ahyp:hlinkClr xmlns:ahyp="http://schemas.microsoft.com/office/drawing/2018/hyperlinkcolor" xmlns="" val="tx"/>
                     </a:ext>
                   </a:extLst>
                 </a:hlinkClick>
@@ -9082,7 +9083,7 @@
             <a:fld id="{1D8BD707-D9CF-40AE-B4C6-C98DA3205C09}" type="datetimeFigureOut">
               <a:rPr lang="en-US" smtClean="0"/>
               <a:pPr/>
-              <a:t>3/27/2024</a:t>
+              <a:t>3/28/2024</a:t>
             </a:fld>
             <a:endParaRPr lang="en-US"/>
           </a:p>
@@ -9324,7 +9325,7 @@
             <a:fld id="{1D8BD707-D9CF-40AE-B4C6-C98DA3205C09}" type="datetimeFigureOut">
               <a:rPr lang="en-US" smtClean="0"/>
               <a:pPr/>
-              <a:t>3/27/2024</a:t>
+              <a:t>3/28/2024</a:t>
             </a:fld>
             <a:endParaRPr lang="en-US"/>
           </a:p>
@@ -9606,7 +9607,7 @@
             <a:fld id="{1D8BD707-D9CF-40AE-B4C6-C98DA3205C09}" type="datetimeFigureOut">
               <a:rPr lang="en-US" smtClean="0"/>
               <a:pPr/>
-              <a:t>3/27/2024</a:t>
+              <a:t>3/28/2024</a:t>
             </a:fld>
             <a:endParaRPr lang="en-US"/>
           </a:p>
@@ -10022,7 +10023,7 @@
             <a:fld id="{1D8BD707-D9CF-40AE-B4C6-C98DA3205C09}" type="datetimeFigureOut">
               <a:rPr lang="en-US" smtClean="0"/>
               <a:pPr/>
-              <a:t>3/27/2024</a:t>
+              <a:t>3/28/2024</a:t>
             </a:fld>
             <a:endParaRPr lang="en-US"/>
           </a:p>
@@ -10136,7 +10137,7 @@
             <a:fld id="{1D8BD707-D9CF-40AE-B4C6-C98DA3205C09}" type="datetimeFigureOut">
               <a:rPr lang="en-US" smtClean="0"/>
               <a:pPr/>
-              <a:t>3/27/2024</a:t>
+              <a:t>3/28/2024</a:t>
             </a:fld>
             <a:endParaRPr lang="en-US"/>
           </a:p>
@@ -10228,7 +10229,7 @@
             <a:fld id="{1D8BD707-D9CF-40AE-B4C6-C98DA3205C09}" type="datetimeFigureOut">
               <a:rPr lang="en-US" smtClean="0"/>
               <a:pPr/>
-              <a:t>3/27/2024</a:t>
+              <a:t>3/28/2024</a:t>
             </a:fld>
             <a:endParaRPr lang="en-US"/>
           </a:p>
@@ -10500,7 +10501,7 @@
             <a:fld id="{1D8BD707-D9CF-40AE-B4C6-C98DA3205C09}" type="datetimeFigureOut">
               <a:rPr lang="en-US" smtClean="0"/>
               <a:pPr/>
-              <a:t>3/27/2024</a:t>
+              <a:t>3/28/2024</a:t>
             </a:fld>
             <a:endParaRPr lang="en-US"/>
           </a:p>
@@ -10749,7 +10750,7 @@
             <a:fld id="{1D8BD707-D9CF-40AE-B4C6-C98DA3205C09}" type="datetimeFigureOut">
               <a:rPr lang="en-US" smtClean="0"/>
               <a:pPr/>
-              <a:t>3/27/2024</a:t>
+              <a:t>3/28/2024</a:t>
             </a:fld>
             <a:endParaRPr lang="en-US"/>
           </a:p>
@@ -10957,7 +10958,7 @@
             <a:fld id="{1D8BD707-D9CF-40AE-B4C6-C98DA3205C09}" type="datetimeFigureOut">
               <a:rPr lang="en-US" smtClean="0"/>
               <a:pPr/>
-              <a:t>3/27/2024</a:t>
+              <a:t>3/28/2024</a:t>
             </a:fld>
             <a:endParaRPr lang="en-US"/>
           </a:p>
@@ -12067,6 +12068,108 @@
 </file>
 
 <file path=ppt/slides/slide10.xml><?xml version="1.0" encoding="utf-8"?>
+<p:sld xmlns:a="http://schemas.openxmlformats.org/drawingml/2006/main" xmlns:r="http://schemas.openxmlformats.org/officeDocument/2006/relationships" xmlns:p="http://schemas.openxmlformats.org/presentationml/2006/main">
+  <p:cSld>
+    <p:spTree>
+      <p:nvGrpSpPr>
+        <p:cNvPr id="1" name=""/>
+        <p:cNvGrpSpPr/>
+        <p:nvPr/>
+      </p:nvGrpSpPr>
+      <p:grpSpPr>
+        <a:xfrm>
+          <a:off x="0" y="0"/>
+          <a:ext cx="0" cy="0"/>
+          <a:chOff x="0" y="0"/>
+          <a:chExt cx="0" cy="0"/>
+        </a:xfrm>
+      </p:grpSpPr>
+      <p:pic>
+        <p:nvPicPr>
+          <p:cNvPr id="4" name="Picture 3"/>
+          <p:cNvPicPr>
+            <a:picLocks noChangeAspect="1"/>
+          </p:cNvPicPr>
+          <p:nvPr/>
+        </p:nvPicPr>
+        <p:blipFill>
+          <a:blip r:embed="rId2">
+            <a:extLst>
+              <a:ext uri="{28A0092B-C50C-407E-A947-70E740481C1C}">
+                <a14:useLocalDpi xmlns:a14="http://schemas.microsoft.com/office/drawing/2010/main" val="0"/>
+              </a:ext>
+            </a:extLst>
+          </a:blip>
+          <a:stretch>
+            <a:fillRect/>
+          </a:stretch>
+        </p:blipFill>
+        <p:spPr>
+          <a:xfrm>
+            <a:off x="457200" y="304800"/>
+            <a:ext cx="8275013" cy="5789585"/>
+          </a:xfrm>
+          <a:prstGeom prst="rect">
+            <a:avLst/>
+          </a:prstGeom>
+        </p:spPr>
+      </p:pic>
+      <p:sp>
+        <p:nvSpPr>
+          <p:cNvPr id="6" name="TextBox 5"/>
+          <p:cNvSpPr txBox="1"/>
+          <p:nvPr/>
+        </p:nvSpPr>
+        <p:spPr>
+          <a:xfrm>
+            <a:off x="1652828" y="6231128"/>
+            <a:ext cx="5883756" cy="338554"/>
+          </a:xfrm>
+          <a:prstGeom prst="rect">
+            <a:avLst/>
+          </a:prstGeom>
+          <a:noFill/>
+        </p:spPr>
+        <p:txBody>
+          <a:bodyPr wrap="square" rtlCol="0">
+            <a:spAutoFit/>
+          </a:bodyPr>
+          <a:lstStyle/>
+          <a:p>
+            <a:pPr algn="ctr"/>
+            <a:r>
+              <a:rPr lang="en-GB" sz="1600" b="1" dirty="0" smtClean="0"/>
+              <a:t>Figure 3 : General </a:t>
+            </a:r>
+            <a:r>
+              <a:rPr lang="en-GB" sz="1600" b="1" dirty="0" smtClean="0"/>
+              <a:t>structure and components logic implementation</a:t>
+            </a:r>
+            <a:endParaRPr lang="en-GB" sz="1600" b="1" dirty="0"/>
+          </a:p>
+        </p:txBody>
+      </p:sp>
+    </p:spTree>
+    <p:extLst>
+      <p:ext uri="{BB962C8B-B14F-4D97-AF65-F5344CB8AC3E}">
+        <p14:creationId xmlns:p14="http://schemas.microsoft.com/office/powerpoint/2010/main" val="595162780"/>
+      </p:ext>
+    </p:extLst>
+  </p:cSld>
+  <p:clrMapOvr>
+    <a:masterClrMapping/>
+  </p:clrMapOvr>
+  <p:timing>
+    <p:tnLst>
+      <p:par>
+        <p:cTn id="1" dur="indefinite" restart="never" nodeType="tmRoot"/>
+      </p:par>
+    </p:tnLst>
+  </p:timing>
+</p:sld>
+</file>
+
+<file path=ppt/slides/slide11.xml><?xml version="1.0" encoding="utf-8"?>
 <p:sld xmlns:a="http://schemas.openxmlformats.org/drawingml/2006/main" xmlns:r="http://schemas.openxmlformats.org/officeDocument/2006/relationships" xmlns:p="http://schemas.openxmlformats.org/presentationml/2006/main">
   <p:cSld>
     <p:spTree>
@@ -13808,7 +13911,7 @@
 </p:sld>
 </file>
 
-<file path=ppt/slides/slide11.xml><?xml version="1.0" encoding="utf-8"?>
+<file path=ppt/slides/slide12.xml><?xml version="1.0" encoding="utf-8"?>
 <p:sld xmlns:a="http://schemas.openxmlformats.org/drawingml/2006/main" xmlns:r="http://schemas.openxmlformats.org/officeDocument/2006/relationships" xmlns:p="http://schemas.openxmlformats.org/presentationml/2006/main">
   <p:cSld>
     <p:spTree>
@@ -14220,7 +14323,7 @@
 </p:sld>
 </file>
 
-<file path=ppt/slides/slide12.xml><?xml version="1.0" encoding="utf-8"?>
+<file path=ppt/slides/slide13.xml><?xml version="1.0" encoding="utf-8"?>
 <p:sld xmlns:a="http://schemas.openxmlformats.org/drawingml/2006/main" xmlns:r="http://schemas.openxmlformats.org/officeDocument/2006/relationships" xmlns:p="http://schemas.openxmlformats.org/presentationml/2006/main">
   <p:cSld>
     <p:spTree>
@@ -14656,7 +14759,7 @@
 </p:sld>
 </file>
 
-<file path=ppt/slides/slide13.xml><?xml version="1.0" encoding="utf-8"?>
+<file path=ppt/slides/slide14.xml><?xml version="1.0" encoding="utf-8"?>
 <p:sld xmlns:a="http://schemas.openxmlformats.org/drawingml/2006/main" xmlns:r="http://schemas.openxmlformats.org/officeDocument/2006/relationships" xmlns:p="http://schemas.openxmlformats.org/presentationml/2006/main">
   <p:cSld>
     <p:spTree>
@@ -15119,7 +15222,7 @@
 </p:sld>
 </file>
 
-<file path=ppt/slides/slide14.xml><?xml version="1.0" encoding="utf-8"?>
+<file path=ppt/slides/slide15.xml><?xml version="1.0" encoding="utf-8"?>
 <p:sld xmlns:a="http://schemas.openxmlformats.org/drawingml/2006/main" xmlns:r="http://schemas.openxmlformats.org/officeDocument/2006/relationships" xmlns:p="http://schemas.openxmlformats.org/presentationml/2006/main">
   <p:cSld>
     <p:spTree>
@@ -15701,7 +15804,7 @@
 </p:sld>
 </file>
 
-<file path=ppt/slides/slide15.xml><?xml version="1.0" encoding="utf-8"?>
+<file path=ppt/slides/slide16.xml><?xml version="1.0" encoding="utf-8"?>
 <p:sld xmlns:a="http://schemas.openxmlformats.org/drawingml/2006/main" xmlns:r="http://schemas.openxmlformats.org/officeDocument/2006/relationships" xmlns:p="http://schemas.openxmlformats.org/presentationml/2006/main">
   <p:cSld>
     <p:spTree>
@@ -15889,6 +15992,74 @@
           </a:p>
         </p:txBody>
       </p:sp>
+      <p:sp>
+        <p:nvSpPr>
+          <p:cNvPr id="6" name="TextBox 5"/>
+          <p:cNvSpPr txBox="1"/>
+          <p:nvPr/>
+        </p:nvSpPr>
+        <p:spPr>
+          <a:xfrm>
+            <a:off x="342900" y="2438400"/>
+            <a:ext cx="8458200" cy="523220"/>
+          </a:xfrm>
+          <a:prstGeom prst="rect">
+            <a:avLst/>
+          </a:prstGeom>
+          <a:noFill/>
+        </p:spPr>
+        <p:txBody>
+          <a:bodyPr wrap="square" rtlCol="0">
+            <a:spAutoFit/>
+          </a:bodyPr>
+          <a:lstStyle/>
+          <a:p>
+            <a:r>
+              <a:rPr lang="en-GB" sz="1400" dirty="0" smtClean="0"/>
+              <a:t>[2] Microsoft Documentation</a:t>
+            </a:r>
+            <a:r>
+              <a:rPr lang="en-GB" sz="1400" dirty="0"/>
+              <a:t>, “The Model-View-</a:t>
+            </a:r>
+            <a:r>
+              <a:rPr lang="en-GB" sz="1400" dirty="0" err="1"/>
+              <a:t>ViewModel</a:t>
+            </a:r>
+            <a:r>
+              <a:rPr lang="en-GB" sz="1400" dirty="0"/>
+              <a:t> Pattern</a:t>
+            </a:r>
+            <a:r>
+              <a:rPr lang="en-GB" sz="1400" dirty="0" smtClean="0"/>
+              <a:t>”, </a:t>
+            </a:r>
+            <a:r>
+              <a:rPr lang="en-GB" sz="1400" dirty="0" err="1" smtClean="0"/>
+              <a:t>Xamarin.Forms</a:t>
+            </a:r>
+            <a:r>
+              <a:rPr lang="en-GB" sz="1400" dirty="0" smtClean="0"/>
+              <a:t>, 2021</a:t>
+            </a:r>
+            <a:r>
+              <a:rPr lang="en-GB" sz="1400" dirty="0" smtClean="0"/>
+              <a:t>. Accessed on: </a:t>
+            </a:r>
+            <a:r>
+              <a:rPr lang="en-GB" sz="1400" dirty="0" smtClean="0">
+                <a:hlinkClick r:id="rId5"/>
+              </a:rPr>
+              <a:t>https://learn.microsoft.com/en-us/xamarin/xamarin-forms/enterprise-application-patterns/mvvm</a:t>
+            </a:r>
+            <a:r>
+              <a:rPr lang="en-GB" sz="1400" dirty="0" smtClean="0"/>
+              <a:t> . </a:t>
+            </a:r>
+            <a:endParaRPr lang="en-GB" sz="1400" dirty="0" smtClean="0"/>
+          </a:p>
+        </p:txBody>
+      </p:sp>
     </p:spTree>
     <p:extLst>
       <p:ext uri="{BB962C8B-B14F-4D97-AF65-F5344CB8AC3E}">
@@ -15909,7 +16080,7 @@
 </p:sld>
 </file>
 
-<file path=ppt/slides/slide16.xml><?xml version="1.0" encoding="utf-8"?>
+<file path=ppt/slides/slide17.xml><?xml version="1.0" encoding="utf-8"?>
 <p:sld xmlns:a="http://schemas.openxmlformats.org/drawingml/2006/main" xmlns:r="http://schemas.openxmlformats.org/officeDocument/2006/relationships" xmlns:p="http://schemas.openxmlformats.org/presentationml/2006/main">
   <p:cSld>
     <p:spTree>
@@ -17166,11 +17337,7 @@
             </a:r>
             <a:r>
               <a:rPr lang="en-GB" sz="2000" dirty="0" smtClean="0"/>
-              <a:t> </a:t>
-            </a:r>
-            <a:r>
-              <a:rPr lang="en-GB" sz="2000" dirty="0" smtClean="0"/>
-              <a:t>Install </a:t>
+              <a:t> Install </a:t>
             </a:r>
             <a:r>
               <a:rPr lang="en-GB" sz="2000" dirty="0"/>
@@ -17601,11 +17768,7 @@
             <a:pPr algn="ctr"/>
             <a:r>
               <a:rPr lang="en-GB" sz="1600" b="1" dirty="0" smtClean="0"/>
-              <a:t>Figure </a:t>
-            </a:r>
-            <a:r>
-              <a:rPr lang="en-GB" sz="1600" b="1" dirty="0" smtClean="0"/>
-              <a:t>2: General structure of </a:t>
+              <a:t>Figure 2: General structure of </a:t>
             </a:r>
             <a:r>
               <a:rPr lang="en-GB" sz="1600" b="1" dirty="0" err="1" smtClean="0"/>
@@ -18409,7 +18572,7 @@
         <p:spPr>
           <a:xfrm>
             <a:off x="0" y="1219200"/>
-            <a:ext cx="3581400" cy="553998"/>
+            <a:ext cx="6324600" cy="553998"/>
           </a:xfrm>
           <a:prstGeom prst="rect">
             <a:avLst/>
@@ -18423,8 +18586,12 @@
           <a:lstStyle/>
           <a:p>
             <a:r>
+              <a:rPr lang="en-GB" sz="3000" u="sng" dirty="0"/>
+              <a:t>b</a:t>
+            </a:r>
+            <a:r>
               <a:rPr lang="en-GB" sz="3000" u="sng" dirty="0" smtClean="0"/>
-              <a:t>a. UI implementation</a:t>
+              <a:t>. SDR drawing library implementation</a:t>
             </a:r>
             <a:endParaRPr lang="en-GB" sz="3000" u="sng" dirty="0"/>
           </a:p>
@@ -18432,14 +18599,14 @@
       </p:sp>
       <p:sp>
         <p:nvSpPr>
-          <p:cNvPr id="7" name="TextBox 6"/>
+          <p:cNvPr id="2" name="TextBox 1"/>
           <p:cNvSpPr txBox="1"/>
           <p:nvPr/>
         </p:nvSpPr>
         <p:spPr>
           <a:xfrm>
-            <a:off x="3409950" y="6205729"/>
-            <a:ext cx="4914900" cy="338554"/>
+            <a:off x="685800" y="2133600"/>
+            <a:ext cx="7543800" cy="3416320"/>
           </a:xfrm>
           <a:prstGeom prst="rect">
             <a:avLst/>
@@ -18452,23 +18619,121 @@
           </a:bodyPr>
           <a:lstStyle/>
           <a:p>
-            <a:pPr algn="ctr"/>
-            <a:r>
-              <a:rPr lang="en-GB" sz="1600" b="1" dirty="0" smtClean="0"/>
-              <a:t>Figure </a:t>
-            </a:r>
-            <a:r>
-              <a:rPr lang="en-GB" sz="1600" b="1" dirty="0" smtClean="0"/>
-              <a:t>:</a:t>
-            </a:r>
-            <a:endParaRPr lang="en-GB" sz="1600" b="1" dirty="0"/>
+            <a:pPr>
+              <a:lnSpc>
+                <a:spcPct val="200000"/>
+              </a:lnSpc>
+            </a:pPr>
+            <a:r>
+              <a:rPr lang="en-GB" dirty="0"/>
+              <a:t>The primary idea of all drawing functions is based on three </a:t>
+            </a:r>
+            <a:r>
+              <a:rPr lang="en-GB" i="1" dirty="0" err="1"/>
+              <a:t>ICanvas</a:t>
+            </a:r>
+            <a:r>
+              <a:rPr lang="en-GB" dirty="0"/>
+              <a:t> methods:</a:t>
+            </a:r>
+          </a:p>
+          <a:p>
+            <a:pPr marL="285750" indent="-285750">
+              <a:lnSpc>
+                <a:spcPct val="200000"/>
+              </a:lnSpc>
+              <a:buFont typeface="Arial" pitchFamily="34" charset="0"/>
+              <a:buChar char="•"/>
+            </a:pPr>
+            <a:r>
+              <a:rPr lang="en-GB" dirty="0" err="1"/>
+              <a:t>DrawString</a:t>
+            </a:r>
+            <a:r>
+              <a:rPr lang="en-GB" dirty="0"/>
+              <a:t>(string value, float x, float y, </a:t>
+            </a:r>
+            <a:r>
+              <a:rPr lang="en-GB" dirty="0" err="1"/>
+              <a:t>HorizontalAlignment</a:t>
+            </a:r>
+            <a:r>
+              <a:rPr lang="en-GB" dirty="0"/>
+              <a:t> </a:t>
+            </a:r>
+            <a:r>
+              <a:rPr lang="en-GB" dirty="0" err="1"/>
+              <a:t>horizontalAlignment</a:t>
+            </a:r>
+            <a:r>
+              <a:rPr lang="en-GB" dirty="0"/>
+              <a:t>, </a:t>
+            </a:r>
+            <a:r>
+              <a:rPr lang="en-GB" dirty="0" err="1"/>
+              <a:t>VerticalAlignment</a:t>
+            </a:r>
+            <a:r>
+              <a:rPr lang="en-GB" dirty="0"/>
+              <a:t> </a:t>
+            </a:r>
+            <a:r>
+              <a:rPr lang="en-GB" dirty="0" err="1"/>
+              <a:t>verticalAlignment</a:t>
+            </a:r>
+            <a:r>
+              <a:rPr lang="en-GB" dirty="0"/>
+              <a:t>)</a:t>
+            </a:r>
+          </a:p>
+          <a:p>
+            <a:pPr marL="285750" indent="-285750">
+              <a:lnSpc>
+                <a:spcPct val="200000"/>
+              </a:lnSpc>
+              <a:buFont typeface="Arial" pitchFamily="34" charset="0"/>
+              <a:buChar char="•"/>
+            </a:pPr>
+            <a:r>
+              <a:rPr lang="en-GB" dirty="0" err="1"/>
+              <a:t>DrawRectangle</a:t>
+            </a:r>
+            <a:r>
+              <a:rPr lang="en-GB" dirty="0"/>
+              <a:t>(float x, float y, float width, float height)</a:t>
+            </a:r>
+          </a:p>
+          <a:p>
+            <a:pPr marL="285750" indent="-285750">
+              <a:lnSpc>
+                <a:spcPct val="200000"/>
+              </a:lnSpc>
+              <a:buFont typeface="Arial" pitchFamily="34" charset="0"/>
+              <a:buChar char="•"/>
+            </a:pPr>
+            <a:r>
+              <a:rPr lang="en-GB" dirty="0" err="1"/>
+              <a:t>DrawRoundedRectangle</a:t>
+            </a:r>
+            <a:r>
+              <a:rPr lang="en-GB" dirty="0"/>
+              <a:t>(float x, float y, float width, float height, float </a:t>
+            </a:r>
+            <a:r>
+              <a:rPr lang="en-GB" dirty="0" err="1"/>
+              <a:t>cornerRadius</a:t>
+            </a:r>
+            <a:r>
+              <a:rPr lang="en-GB" dirty="0"/>
+              <a:t>)</a:t>
+            </a:r>
           </a:p>
         </p:txBody>
       </p:sp>
     </p:spTree>
     <p:extLst>
       <p:ext uri="{BB962C8B-B14F-4D97-AF65-F5344CB8AC3E}">
-        <p14:creationId xmlns:p14="http://schemas.microsoft.com/office/powerpoint/2010/main" val="1269763602"/>
+        <p14:creationId xmlns:p14="http://schemas.microsoft.com/office/powerpoint/2010/main" val="2823905067"/>
       </p:ext>
     </p:extLst>
   </p:cSld>
@@ -18774,20 +19039,93 @@
             </a:r>
             <a:r>
               <a:rPr lang="en-GB" sz="3000" u="sng" dirty="0" smtClean="0"/>
-              <a:t>. </a:t>
-            </a:r>
-            <a:r>
-              <a:rPr lang="en-GB" sz="3000" u="sng" dirty="0" smtClean="0"/>
-              <a:t>SDR drawing library implementation</a:t>
+              <a:t>. SDR drawing library implementation</a:t>
             </a:r>
             <a:endParaRPr lang="en-GB" sz="3000" u="sng" dirty="0"/>
+          </a:p>
+        </p:txBody>
+      </p:sp>
+      <p:pic>
+        <p:nvPicPr>
+          <p:cNvPr id="2" name="Picture 1"/>
+          <p:cNvPicPr>
+            <a:picLocks noChangeAspect="1"/>
+          </p:cNvPicPr>
+          <p:nvPr/>
+        </p:nvPicPr>
+        <p:blipFill>
+          <a:blip r:embed="rId4">
+            <a:extLst>
+              <a:ext uri="{28A0092B-C50C-407E-A947-70E740481C1C}">
+                <a14:useLocalDpi xmlns:a14="http://schemas.microsoft.com/office/drawing/2010/main" val="0"/>
+              </a:ext>
+            </a:extLst>
+          </a:blip>
+          <a:stretch>
+            <a:fillRect/>
+          </a:stretch>
+        </p:blipFill>
+        <p:spPr>
+          <a:xfrm>
+            <a:off x="0" y="1773198"/>
+            <a:ext cx="9144000" cy="4393566"/>
+          </a:xfrm>
+          <a:prstGeom prst="rect">
+            <a:avLst/>
+          </a:prstGeom>
+        </p:spPr>
+      </p:pic>
+      <p:sp>
+        <p:nvSpPr>
+          <p:cNvPr id="7" name="TextBox 6"/>
+          <p:cNvSpPr txBox="1"/>
+          <p:nvPr/>
+        </p:nvSpPr>
+        <p:spPr>
+          <a:xfrm>
+            <a:off x="1600200" y="6375006"/>
+            <a:ext cx="6400800" cy="338554"/>
+          </a:xfrm>
+          <a:prstGeom prst="rect">
+            <a:avLst/>
+          </a:prstGeom>
+          <a:noFill/>
+        </p:spPr>
+        <p:txBody>
+          <a:bodyPr wrap="square" rtlCol="0">
+            <a:spAutoFit/>
+          </a:bodyPr>
+          <a:lstStyle/>
+          <a:p>
+            <a:pPr algn="ctr"/>
+            <a:r>
+              <a:rPr lang="en-GB" sz="1600" b="1" dirty="0" smtClean="0"/>
+              <a:t>Figure 3 : General </a:t>
+            </a:r>
+            <a:r>
+              <a:rPr lang="en-GB" sz="1600" b="1" dirty="0" smtClean="0"/>
+              <a:t>visualisation components of </a:t>
+            </a:r>
+            <a:r>
+              <a:rPr lang="en-GB" sz="1600" b="1" dirty="0" err="1" smtClean="0"/>
+              <a:t>SdrDrawer</a:t>
+            </a:r>
+            <a:r>
+              <a:rPr lang="en-GB" sz="1600" b="1" dirty="0" err="1" smtClean="0"/>
+              <a:t>Lib</a:t>
+            </a:r>
+            <a:r>
+              <a:rPr lang="en-GB" sz="1600" b="1" dirty="0" smtClean="0"/>
+              <a:t> library</a:t>
+            </a:r>
+            <a:endParaRPr lang="en-GB" sz="1600" b="1" dirty="0"/>
           </a:p>
         </p:txBody>
       </p:sp>
     </p:spTree>
     <p:extLst>
       <p:ext uri="{BB962C8B-B14F-4D97-AF65-F5344CB8AC3E}">
-        <p14:creationId xmlns:p14="http://schemas.microsoft.com/office/powerpoint/2010/main" val="2823905067"/>
+        <p14:creationId xmlns:p14="http://schemas.microsoft.com/office/powerpoint/2010/main" val="2912181094"/>
       </p:ext>
     </p:extLst>
   </p:cSld>
@@ -18829,7 +19167,7 @@
         </p:nvCxnSpPr>
         <p:spPr>
           <a:xfrm>
-            <a:off x="0" y="1219200"/>
+            <a:off x="0" y="990600"/>
             <a:ext cx="9144000" cy="0"/>
           </a:xfrm>
           <a:prstGeom prst="line">
@@ -18885,7 +19223,7 @@
         </p:nvSpPr>
         <p:spPr>
           <a:xfrm>
-            <a:off x="1524000" y="442058"/>
+            <a:off x="1524000" y="116117"/>
             <a:ext cx="6553200" cy="768000"/>
           </a:xfrm>
           <a:prstGeom prst="rect">
@@ -19073,7 +19411,7 @@
         </p:nvSpPr>
         <p:spPr>
           <a:xfrm>
-            <a:off x="0" y="1219200"/>
+            <a:off x="-8467" y="990600"/>
             <a:ext cx="4114800" cy="553998"/>
           </a:xfrm>
           <a:prstGeom prst="rect">
@@ -19093,13 +19431,228 @@
             </a:r>
             <a:r>
               <a:rPr lang="en-GB" sz="3000" u="sng" dirty="0" smtClean="0"/>
-              <a:t>. </a:t>
-            </a:r>
-            <a:r>
-              <a:rPr lang="en-GB" sz="3000" u="sng" dirty="0" smtClean="0"/>
-              <a:t>Logic implementation</a:t>
+              <a:t>. Logic implementation</a:t>
             </a:r>
             <a:endParaRPr lang="en-GB" sz="3000" u="sng" dirty="0"/>
+          </a:p>
+        </p:txBody>
+      </p:sp>
+      <p:sp>
+        <p:nvSpPr>
+          <p:cNvPr id="5" name="Rectangle 4"/>
+          <p:cNvSpPr/>
+          <p:nvPr/>
+        </p:nvSpPr>
+        <p:spPr>
+          <a:xfrm>
+            <a:off x="228600" y="1992535"/>
+            <a:ext cx="4800600" cy="3416320"/>
+          </a:xfrm>
+          <a:prstGeom prst="rect">
+            <a:avLst/>
+          </a:prstGeom>
+        </p:spPr>
+        <p:txBody>
+          <a:bodyPr wrap="square">
+            <a:spAutoFit/>
+          </a:bodyPr>
+          <a:lstStyle/>
+          <a:p>
+            <a:pPr>
+              <a:lnSpc>
+                <a:spcPct val="200000"/>
+              </a:lnSpc>
+            </a:pPr>
+            <a:r>
+              <a:rPr lang="en-GB" dirty="0" smtClean="0"/>
+              <a:t>1. UI </a:t>
+            </a:r>
+            <a:r>
+              <a:rPr lang="en-GB" dirty="0"/>
+              <a:t>Files and Direct Logic: Each UI file has its own code-behind (*.</a:t>
+            </a:r>
+            <a:r>
+              <a:rPr lang="en-GB" dirty="0" err="1"/>
+              <a:t>xaml.cs</a:t>
+            </a:r>
+            <a:r>
+              <a:rPr lang="en-GB" dirty="0"/>
+              <a:t>) for simple logic</a:t>
+            </a:r>
+            <a:r>
+              <a:rPr lang="en-GB" dirty="0" smtClean="0"/>
+              <a:t>.</a:t>
+            </a:r>
+            <a:endParaRPr lang="en-GB" dirty="0"/>
+          </a:p>
+          <a:p>
+            <a:pPr>
+              <a:lnSpc>
+                <a:spcPct val="200000"/>
+              </a:lnSpc>
+            </a:pPr>
+            <a:r>
+              <a:rPr lang="en-GB" dirty="0" smtClean="0"/>
+              <a:t>2. MVVM </a:t>
+            </a:r>
+            <a:r>
+              <a:rPr lang="en-GB" dirty="0"/>
+              <a:t>Pattern</a:t>
+            </a:r>
+            <a:r>
+              <a:rPr lang="en-GB" dirty="0" smtClean="0"/>
+              <a:t>:</a:t>
+            </a:r>
+            <a:endParaRPr lang="en-GB" dirty="0"/>
+          </a:p>
+          <a:p>
+            <a:pPr marL="285750" indent="-285750">
+              <a:lnSpc>
+                <a:spcPct val="200000"/>
+              </a:lnSpc>
+              <a:buFont typeface="Arial" pitchFamily="34" charset="0"/>
+              <a:buChar char="•"/>
+            </a:pPr>
+            <a:r>
+              <a:rPr lang="en-GB" dirty="0"/>
+              <a:t>For complex logic, use </a:t>
+            </a:r>
+            <a:r>
+              <a:rPr lang="en-GB" dirty="0" smtClean="0"/>
+              <a:t>MVVM [2].</a:t>
+            </a:r>
+            <a:endParaRPr lang="en-GB" dirty="0"/>
+          </a:p>
+          <a:p>
+            <a:pPr marL="285750" indent="-285750">
+              <a:lnSpc>
+                <a:spcPct val="200000"/>
+              </a:lnSpc>
+              <a:buFont typeface="Arial" pitchFamily="34" charset="0"/>
+              <a:buChar char="•"/>
+            </a:pPr>
+            <a:r>
+              <a:rPr lang="en-GB" dirty="0"/>
+              <a:t>Separate </a:t>
+            </a:r>
+            <a:r>
+              <a:rPr lang="en-GB" dirty="0" err="1"/>
+              <a:t>ViewModels</a:t>
+            </a:r>
+            <a:r>
+              <a:rPr lang="en-GB" dirty="0"/>
+              <a:t> (</a:t>
+            </a:r>
+            <a:r>
+              <a:rPr lang="en-GB" dirty="0" err="1"/>
+              <a:t>MainViewModel.cs</a:t>
+            </a:r>
+            <a:r>
+              <a:rPr lang="en-GB" dirty="0"/>
+              <a:t>, Page1ViewModel.cs) handle data and logic</a:t>
+            </a:r>
+            <a:r>
+              <a:rPr lang="en-GB" dirty="0" smtClean="0"/>
+              <a:t>.</a:t>
+            </a:r>
+            <a:endParaRPr lang="en-GB" dirty="0"/>
+          </a:p>
+        </p:txBody>
+      </p:sp>
+      <p:sp>
+        <p:nvSpPr>
+          <p:cNvPr id="7" name="Rectangle 6"/>
+          <p:cNvSpPr/>
+          <p:nvPr/>
+        </p:nvSpPr>
+        <p:spPr>
+          <a:xfrm>
+            <a:off x="5257800" y="1989667"/>
+            <a:ext cx="3733800" cy="3338735"/>
+          </a:xfrm>
+          <a:prstGeom prst="rect">
+            <a:avLst/>
+          </a:prstGeom>
+        </p:spPr>
+        <p:txBody>
+          <a:bodyPr wrap="square">
+            <a:spAutoFit/>
+          </a:bodyPr>
+          <a:lstStyle/>
+          <a:p>
+            <a:pPr>
+              <a:lnSpc>
+                <a:spcPct val="200000"/>
+              </a:lnSpc>
+            </a:pPr>
+            <a:r>
+              <a:rPr lang="en-GB" dirty="0"/>
+              <a:t>3. MVVM Benefits:</a:t>
+            </a:r>
+          </a:p>
+          <a:p>
+            <a:pPr marL="285750" indent="-285750">
+              <a:lnSpc>
+                <a:spcPct val="200000"/>
+              </a:lnSpc>
+              <a:buFont typeface="Arial" pitchFamily="34" charset="0"/>
+              <a:buChar char="•"/>
+            </a:pPr>
+            <a:r>
+              <a:rPr lang="en-GB" dirty="0"/>
+              <a:t>Cleaner code organization.</a:t>
+            </a:r>
+          </a:p>
+          <a:p>
+            <a:pPr marL="285750" indent="-285750">
+              <a:lnSpc>
+                <a:spcPct val="200000"/>
+              </a:lnSpc>
+              <a:buFont typeface="Arial" pitchFamily="34" charset="0"/>
+              <a:buChar char="•"/>
+            </a:pPr>
+            <a:r>
+              <a:rPr lang="en-GB" dirty="0"/>
+              <a:t>Easier maintenance and testing.</a:t>
+            </a:r>
+          </a:p>
+          <a:p>
+            <a:pPr>
+              <a:lnSpc>
+                <a:spcPct val="200000"/>
+              </a:lnSpc>
+            </a:pPr>
+            <a:r>
+              <a:rPr lang="en-GB" dirty="0"/>
+              <a:t>4. Implementation Guidelines:</a:t>
+            </a:r>
+          </a:p>
+          <a:p>
+            <a:pPr marL="285750" indent="-285750">
+              <a:lnSpc>
+                <a:spcPct val="200000"/>
+              </a:lnSpc>
+              <a:buFont typeface="Arial" pitchFamily="34" charset="0"/>
+              <a:buChar char="•"/>
+            </a:pPr>
+            <a:r>
+              <a:rPr lang="en-GB" dirty="0"/>
+              <a:t>Simple logic in UI code-behind.</a:t>
+            </a:r>
+          </a:p>
+          <a:p>
+            <a:pPr marL="285750" indent="-285750">
+              <a:lnSpc>
+                <a:spcPct val="200000"/>
+              </a:lnSpc>
+              <a:buFont typeface="Arial" pitchFamily="34" charset="0"/>
+              <a:buChar char="•"/>
+            </a:pPr>
+            <a:r>
+              <a:rPr lang="en-GB" dirty="0"/>
+              <a:t>MVVM for complex logic.</a:t>
+            </a:r>
+            <a:endParaRPr lang="en-GB" dirty="0"/>
           </a:p>
         </p:txBody>
       </p:sp>
@@ -19116,9 +19669,126 @@
   <p:timing>
     <p:tnLst>
       <p:par>
-        <p:cTn id="1" dur="indefinite" restart="never" nodeType="tmRoot"/>
+        <p:cTn id="1" dur="indefinite" restart="never" nodeType="tmRoot">
+          <p:childTnLst>
+            <p:seq concurrent="1" nextAc="seek">
+              <p:cTn id="2" dur="indefinite" nodeType="mainSeq">
+                <p:childTnLst>
+                  <p:par>
+                    <p:cTn id="3" fill="hold">
+                      <p:stCondLst>
+                        <p:cond delay="indefinite"/>
+                      </p:stCondLst>
+                      <p:childTnLst>
+                        <p:par>
+                          <p:cTn id="4" fill="hold">
+                            <p:stCondLst>
+                              <p:cond delay="0"/>
+                            </p:stCondLst>
+                            <p:childTnLst>
+                              <p:par>
+                                <p:cTn id="5" presetID="1" presetClass="entr" presetSubtype="0" fill="hold" grpId="0" nodeType="clickEffect">
+                                  <p:stCondLst>
+                                    <p:cond delay="0"/>
+                                  </p:stCondLst>
+                                  <p:childTnLst>
+                                    <p:set>
+                                      <p:cBhvr>
+                                        <p:cTn id="6" dur="1" fill="hold">
+                                          <p:stCondLst>
+                                            <p:cond delay="0"/>
+                                          </p:stCondLst>
+                                        </p:cTn>
+                                        <p:tgtEl>
+                                          <p:spTgt spid="5"/>
+                                        </p:tgtEl>
+                                        <p:attrNameLst>
+                                          <p:attrName>style.visibility</p:attrName>
+                                        </p:attrNameLst>
+                                      </p:cBhvr>
+                                      <p:to>
+                                        <p:strVal val="visible"/>
+                                      </p:to>
+                                    </p:set>
+                                  </p:childTnLst>
+                                </p:cTn>
+                              </p:par>
+                            </p:childTnLst>
+                          </p:cTn>
+                        </p:par>
+                      </p:childTnLst>
+                    </p:cTn>
+                  </p:par>
+                  <p:par>
+                    <p:cTn id="7" fill="hold">
+                      <p:stCondLst>
+                        <p:cond delay="indefinite"/>
+                      </p:stCondLst>
+                      <p:childTnLst>
+                        <p:par>
+                          <p:cTn id="8" fill="hold">
+                            <p:stCondLst>
+                              <p:cond delay="0"/>
+                            </p:stCondLst>
+                            <p:childTnLst>
+                              <p:par>
+                                <p:cTn id="9" presetID="1" presetClass="entr" presetSubtype="0" fill="hold" grpId="0" nodeType="clickEffect">
+                                  <p:stCondLst>
+                                    <p:cond delay="0"/>
+                                  </p:stCondLst>
+                                  <p:childTnLst>
+                                    <p:set>
+                                      <p:cBhvr>
+                                        <p:cTn id="10" dur="1" fill="hold">
+                                          <p:stCondLst>
+                                            <p:cond delay="0"/>
+                                          </p:stCondLst>
+                                        </p:cTn>
+                                        <p:tgtEl>
+                                          <p:spTgt spid="7"/>
+                                        </p:tgtEl>
+                                        <p:attrNameLst>
+                                          <p:attrName>style.visibility</p:attrName>
+                                        </p:attrNameLst>
+                                      </p:cBhvr>
+                                      <p:to>
+                                        <p:strVal val="visible"/>
+                                      </p:to>
+                                    </p:set>
+                                  </p:childTnLst>
+                                </p:cTn>
+                              </p:par>
+                            </p:childTnLst>
+                          </p:cTn>
+                        </p:par>
+                      </p:childTnLst>
+                    </p:cTn>
+                  </p:par>
+                </p:childTnLst>
+              </p:cTn>
+              <p:prevCondLst>
+                <p:cond evt="onPrev" delay="0">
+                  <p:tgtEl>
+                    <p:sldTgt/>
+                  </p:tgtEl>
+                </p:cond>
+              </p:prevCondLst>
+              <p:nextCondLst>
+                <p:cond evt="onNext" delay="0">
+                  <p:tgtEl>
+                    <p:sldTgt/>
+                  </p:tgtEl>
+                </p:cond>
+              </p:nextCondLst>
+            </p:seq>
+          </p:childTnLst>
+        </p:cTn>
       </p:par>
     </p:tnLst>
+    <p:bldLst>
+      <p:bldP spid="5" grpId="0"/>
+      <p:bldP spid="7" grpId="0"/>
+    </p:bldLst>
   </p:timing>
 </p:sld>
 </file>

</xml_diff>